<commit_message>
Embed dedicated master repo https://github.com/hrlpavan/omnitransform-ai-resources directly into PPTX slides 1, 3, and 6
</commit_message>
<xml_diff>
--- a/SIH2026_Idea_Presentation_PS26154.pptx
+++ b/SIH2026_Idea_Presentation_PS26154.pptx
@@ -3101,8 +3101,8 @@
         </p:nvSpPr>
         <p:spPr>
           <a:xfrm>
-            <a:off x="731520" y="548640"/>
-            <a:ext cx="10698480" cy="731520"/>
+            <a:off x="731520" y="457200"/>
+            <a:ext cx="10698480" cy="640080"/>
           </a:xfrm>
           <a:prstGeom prst="rect">
             <a:avLst/>
@@ -3137,8 +3137,8 @@
         </p:nvSpPr>
         <p:spPr>
           <a:xfrm>
-            <a:off x="731520" y="1463040"/>
-            <a:ext cx="7498079" cy="4754880"/>
+            <a:off x="731520" y="1280160"/>
+            <a:ext cx="7680960" cy="4937760"/>
           </a:xfrm>
           <a:prstGeom prst="rect">
             <a:avLst/>
@@ -3153,11 +3153,11 @@
           <a:p>
             <a:pPr>
               <a:spcAft>
-                <a:spcPts val="1400"/>
+                <a:spcPts val="1000"/>
               </a:spcAft>
             </a:pPr>
             <a:r>
-              <a:rPr b="1" sz="1800">
+              <a:rPr b="1" sz="1750">
                 <a:solidFill>
                   <a:srgbClr val="141414"/>
                 </a:solidFill>
@@ -3166,7 +3166,7 @@
               <a:t>• Problem Statement ID – </a:t>
             </a:r>
             <a:r>
-              <a:rPr b="1" sz="1800">
+              <a:rPr b="1" sz="1750" u="none">
                 <a:solidFill>
                   <a:srgbClr val="141414"/>
                 </a:solidFill>
@@ -3178,11 +3178,11 @@
           <a:p>
             <a:pPr>
               <a:spcAft>
-                <a:spcPts val="1400"/>
+                <a:spcPts val="1000"/>
               </a:spcAft>
             </a:pPr>
             <a:r>
-              <a:rPr b="1" sz="1800">
+              <a:rPr b="1" sz="1750">
                 <a:solidFill>
                   <a:srgbClr val="141414"/>
                 </a:solidFill>
@@ -3191,7 +3191,7 @@
               <a:t>• Problem Statement Title - </a:t>
             </a:r>
             <a:r>
-              <a:rPr b="1" sz="1800">
+              <a:rPr b="1" sz="1750" u="none">
                 <a:solidFill>
                   <a:srgbClr val="141414"/>
                 </a:solidFill>
@@ -3203,11 +3203,11 @@
           <a:p>
             <a:pPr>
               <a:spcAft>
-                <a:spcPts val="1400"/>
+                <a:spcPts val="1000"/>
               </a:spcAft>
             </a:pPr>
             <a:r>
-              <a:rPr b="1" sz="1800">
+              <a:rPr b="1" sz="1750">
                 <a:solidFill>
                   <a:srgbClr val="141414"/>
                 </a:solidFill>
@@ -3216,7 +3216,7 @@
               <a:t>• Theme - </a:t>
             </a:r>
             <a:r>
-              <a:rPr b="0" sz="1800">
+              <a:rPr b="0" sz="1750" u="none">
                 <a:solidFill>
                   <a:srgbClr val="141414"/>
                 </a:solidFill>
@@ -3228,11 +3228,11 @@
           <a:p>
             <a:pPr>
               <a:spcAft>
-                <a:spcPts val="1400"/>
+                <a:spcPts val="1000"/>
               </a:spcAft>
             </a:pPr>
             <a:r>
-              <a:rPr b="1" sz="1800">
+              <a:rPr b="1" sz="1750">
                 <a:solidFill>
                   <a:srgbClr val="141414"/>
                 </a:solidFill>
@@ -3241,7 +3241,7 @@
               <a:t>• PS Category - </a:t>
             </a:r>
             <a:r>
-              <a:rPr b="0" sz="1800">
+              <a:rPr b="0" sz="1750" u="none">
                 <a:solidFill>
                   <a:srgbClr val="141414"/>
                 </a:solidFill>
@@ -3253,11 +3253,11 @@
           <a:p>
             <a:pPr>
               <a:spcAft>
-                <a:spcPts val="1400"/>
+                <a:spcPts val="1000"/>
               </a:spcAft>
             </a:pPr>
             <a:r>
-              <a:rPr b="1" sz="1800">
+              <a:rPr b="1" sz="1750">
                 <a:solidFill>
                   <a:srgbClr val="141414"/>
                 </a:solidFill>
@@ -3266,7 +3266,7 @@
               <a:t>• Team ID - </a:t>
             </a:r>
             <a:r>
-              <a:rPr b="0" sz="1800">
+              <a:rPr b="0" sz="1750" u="none">
                 <a:solidFill>
                   <a:srgbClr val="141414"/>
                 </a:solidFill>
@@ -3278,11 +3278,11 @@
           <a:p>
             <a:pPr>
               <a:spcAft>
-                <a:spcPts val="1400"/>
+                <a:spcPts val="1000"/>
               </a:spcAft>
             </a:pPr>
             <a:r>
-              <a:rPr b="1" sz="1800">
+              <a:rPr b="1" sz="1750">
                 <a:solidFill>
                   <a:srgbClr val="141414"/>
                 </a:solidFill>
@@ -3291,13 +3291,38 @@
               <a:t>• Team Name - </a:t>
             </a:r>
             <a:r>
-              <a:rPr b="1" sz="1800">
+              <a:rPr b="1" sz="1750" u="none">
                 <a:solidFill>
                   <a:srgbClr val="141414"/>
                 </a:solidFill>
                 <a:latin typeface="Arial"/>
               </a:rPr>
               <a:t>OmniTransform</a:t>
+            </a:r>
+          </a:p>
+          <a:p>
+            <a:pPr>
+              <a:spcAft>
+                <a:spcPts val="1000"/>
+              </a:spcAft>
+            </a:pPr>
+            <a:r>
+              <a:rPr b="1" sz="1600">
+                <a:solidFill>
+                  <a:srgbClr val="1B365D"/>
+                </a:solidFill>
+                <a:latin typeface="Times New Roman"/>
+              </a:rPr>
+              <a:t>• Project Resources - </a:t>
+            </a:r>
+            <a:r>
+              <a:rPr b="1" sz="1400" u="sng">
+                <a:solidFill>
+                  <a:srgbClr val="0077C8"/>
+                </a:solidFill>
+                <a:latin typeface="Arial"/>
+              </a:rPr>
+              <a:t>https://github.com/hrlpavan/omnitransform-ai-resources</a:t>
             </a:r>
           </a:p>
         </p:txBody>
@@ -4590,7 +4615,7 @@
         <p:spPr>
           <a:xfrm>
             <a:off x="6766560" y="1188720"/>
-            <a:ext cx="4846320" cy="4389120"/>
+            <a:ext cx="4846320" cy="4297680"/>
           </a:xfrm>
           <a:prstGeom prst="rect">
             <a:avLst/>
@@ -4821,8 +4846,8 @@
         </p:nvSpPr>
         <p:spPr>
           <a:xfrm>
-            <a:off x="6766560" y="5623560"/>
-            <a:ext cx="4846320" cy="731520"/>
+            <a:off x="6766560" y="5577840"/>
+            <a:ext cx="4846320" cy="777240"/>
           </a:xfrm>
           <a:prstGeom prst="rect">
             <a:avLst/>
@@ -4836,7 +4861,7 @@
           <a:lstStyle/>
           <a:p>
             <a:pPr>
-              <a:defRPr sz="1500" b="1">
+              <a:defRPr sz="1350" b="1">
                 <a:solidFill>
                   <a:srgbClr val="0077C8"/>
                 </a:solidFill>
@@ -4844,12 +4869,12 @@
               </a:defRPr>
             </a:pPr>
             <a:r>
-              <a:t>APP PROTOTYPE LIVE DEMO LINK</a:t>
+              <a:t>APP PROTOTYPE &amp; RESOURCE REPOSITORY LINK</a:t>
             </a:r>
           </a:p>
           <a:p>
             <a:pPr>
-              <a:defRPr sz="1300" b="1" u="sng">
+              <a:defRPr sz="1200" b="1" u="sng">
                 <a:solidFill>
                   <a:srgbClr val="0077C8"/>
                 </a:solidFill>
@@ -4857,7 +4882,7 @@
               </a:defRPr>
             </a:pPr>
             <a:r>
-              <a:t>https://github.com/hrlpavan/sih-2026-media-problem-statements</a:t>
+              <a:t>https://github.com/hrlpavan/omnitransform-ai-resources</a:t>
             </a:r>
           </a:p>
         </p:txBody>
@@ -6571,8 +6596,8 @@
         </p:nvSpPr>
         <p:spPr>
           <a:xfrm>
-            <a:off x="914400" y="1280160"/>
-            <a:ext cx="10332720" cy="4937760"/>
+            <a:off x="731520" y="1234440"/>
+            <a:ext cx="10698480" cy="5029200"/>
           </a:xfrm>
           <a:prstGeom prst="rect">
             <a:avLst/>
@@ -6587,11 +6612,11 @@
           <a:p>
             <a:pPr>
               <a:spcAft>
-                <a:spcPts val="1200"/>
+                <a:spcPts val="1000"/>
               </a:spcAft>
             </a:pPr>
             <a:r>
-              <a:rPr b="1" sz="1500">
+              <a:rPr b="1" sz="1400">
                 <a:solidFill>
                   <a:srgbClr val="141414"/>
                 </a:solidFill>
@@ -6599,32 +6624,32 @@
               <a:t>❖  </a:t>
             </a:r>
             <a:r>
-              <a:rPr b="1" sz="1400">
+              <a:rPr b="1" sz="1300">
                 <a:solidFill>
                   <a:srgbClr val="1B365D"/>
                 </a:solidFill>
                 <a:latin typeface="Times New Roman"/>
               </a:rPr>
-              <a:t>APP PROTOTYPE LIVE DEMO LINK:  </a:t>
-            </a:r>
-            <a:r>
-              <a:rPr u="sng" sz="1300">
+              <a:t>MASTER RESOURCE REPOSITORY &amp; CODE:  </a:t>
+            </a:r>
+            <a:r>
+              <a:rPr u="sng" sz="1200">
                 <a:solidFill>
                   <a:srgbClr val="0077C8"/>
                 </a:solidFill>
                 <a:latin typeface="Arial"/>
               </a:rPr>
-              <a:t>https://github.com/hrlpavan/sih-2026-media-problem-statements</a:t>
+              <a:t>https://github.com/hrlpavan/omnitransform-ai-resources</a:t>
             </a:r>
           </a:p>
           <a:p>
             <a:pPr>
               <a:spcAft>
-                <a:spcPts val="1200"/>
+                <a:spcPts val="1000"/>
               </a:spcAft>
             </a:pPr>
             <a:r>
-              <a:rPr b="1" sz="1500">
+              <a:rPr b="1" sz="1400">
                 <a:solidFill>
                   <a:srgbClr val="141414"/>
                 </a:solidFill>
@@ -6632,32 +6657,32 @@
               <a:t>❖  </a:t>
             </a:r>
             <a:r>
-              <a:rPr b="1" sz="1400">
+              <a:rPr b="1" sz="1300">
                 <a:solidFill>
                   <a:srgbClr val="1B365D"/>
                 </a:solidFill>
                 <a:latin typeface="Times New Roman"/>
               </a:rPr>
-              <a:t>GITHUB PROJECT REPOSITORY LINK:  </a:t>
-            </a:r>
-            <a:r>
-              <a:rPr u="sng" sz="1300">
+              <a:t>OPEN-SOURCE DATASETS &amp; MODELS GUIDE:  </a:t>
+            </a:r>
+            <a:r>
+              <a:rPr u="sng" sz="1200">
                 <a:solidFill>
                   <a:srgbClr val="0077C8"/>
                 </a:solidFill>
                 <a:latin typeface="Arial"/>
               </a:rPr>
-              <a:t>https://github.com/hrlpavan/sih-2026-media-problem-statements</a:t>
+              <a:t>https://github.com/hrlpavan/omnitransform-ai-resources/blob/main/OPEN_SOURCE_RESOURCES_AND_DATASETS.md</a:t>
             </a:r>
           </a:p>
           <a:p>
             <a:pPr>
               <a:spcAft>
-                <a:spcPts val="1200"/>
+                <a:spcPts val="1000"/>
               </a:spcAft>
             </a:pPr>
             <a:r>
-              <a:rPr b="1" sz="1500">
+              <a:rPr b="1" sz="1400">
                 <a:solidFill>
                   <a:srgbClr val="141414"/>
                 </a:solidFill>
@@ -6665,32 +6690,32 @@
               <a:t>❖  </a:t>
             </a:r>
             <a:r>
-              <a:rPr b="1" sz="1400">
+              <a:rPr b="1" sz="1300">
                 <a:solidFill>
                   <a:srgbClr val="1B365D"/>
                 </a:solidFill>
                 <a:latin typeface="Times New Roman"/>
               </a:rPr>
-              <a:t>SMART INDIA HACKATHON 2026 OFFICIAL PORTAL (PS ID 26154):  </a:t>
-            </a:r>
-            <a:r>
-              <a:rPr u="sng" sz="1300">
+              <a:t>TECHNICAL DEVELOPMENT SPECIFICATION:  </a:t>
+            </a:r>
+            <a:r>
+              <a:rPr u="sng" sz="1200">
                 <a:solidFill>
                   <a:srgbClr val="0077C8"/>
                 </a:solidFill>
                 <a:latin typeface="Arial"/>
               </a:rPr>
-              <a:t>https://www.sih.gov.in/sih2026PS</a:t>
+              <a:t>https://github.com/hrlpavan/omnitransform-ai-resources/blob/main/PROJECT_DEVELOPMENT_SPECIFICATION.md</a:t>
             </a:r>
           </a:p>
           <a:p>
             <a:pPr>
               <a:spcAft>
-                <a:spcPts val="1200"/>
+                <a:spcPts val="1000"/>
               </a:spcAft>
             </a:pPr>
             <a:r>
-              <a:rPr b="1" sz="1500">
+              <a:rPr b="1" sz="1400">
                 <a:solidFill>
                   <a:srgbClr val="141414"/>
                 </a:solidFill>
@@ -6698,32 +6723,32 @@
               <a:t>❖  </a:t>
             </a:r>
             <a:r>
-              <a:rPr b="1" sz="1400">
+              <a:rPr b="1" sz="1300">
                 <a:solidFill>
                   <a:srgbClr val="1B365D"/>
                 </a:solidFill>
                 <a:latin typeface="Times New Roman"/>
               </a:rPr>
-              <a:t>NATIONAL TECHNICAL RESEARCH ORGANISATION (NTRO) PORTAL:  </a:t>
-            </a:r>
-            <a:r>
-              <a:rPr u="sng" sz="1300">
+              <a:t>SMART INDIA HACKATHON 2026 OFFICIAL PORTAL (PS ID 26154):  </a:t>
+            </a:r>
+            <a:r>
+              <a:rPr u="sng" sz="1200">
                 <a:solidFill>
                   <a:srgbClr val="0077C8"/>
                 </a:solidFill>
                 <a:latin typeface="Arial"/>
               </a:rPr>
-              <a:t>https://ntro.gov.in</a:t>
+              <a:t>https://www.sih.gov.in/sih2026PS</a:t>
             </a:r>
           </a:p>
           <a:p>
             <a:pPr>
               <a:spcAft>
-                <a:spcPts val="1200"/>
+                <a:spcPts val="1000"/>
               </a:spcAft>
             </a:pPr>
             <a:r>
-              <a:rPr b="1" sz="1500">
+              <a:rPr b="1" sz="1400">
                 <a:solidFill>
                   <a:srgbClr val="141414"/>
                 </a:solidFill>
@@ -6731,32 +6756,32 @@
               <a:t>❖  </a:t>
             </a:r>
             <a:r>
-              <a:rPr b="1" sz="1400">
+              <a:rPr b="1" sz="1300">
                 <a:solidFill>
                   <a:srgbClr val="1B365D"/>
                 </a:solidFill>
                 <a:latin typeface="Times New Roman"/>
               </a:rPr>
-              <a:t>RESEARCH ON RAG &amp; SOURCE CITATIONS (LEWIS ET AL.):  </a:t>
-            </a:r>
-            <a:r>
-              <a:rPr u="sng" sz="1300">
+              <a:t>NATIONAL TECHNICAL RESEARCH ORGANISATION (NTRO) PORTAL:  </a:t>
+            </a:r>
+            <a:r>
+              <a:rPr u="sng" sz="1200">
                 <a:solidFill>
                   <a:srgbClr val="0077C8"/>
                 </a:solidFill>
                 <a:latin typeface="Arial"/>
               </a:rPr>
-              <a:t>https://arxiv.org/abs/2005.11401</a:t>
+              <a:t>https://ntro.gov.in</a:t>
             </a:r>
           </a:p>
           <a:p>
             <a:pPr>
               <a:spcAft>
-                <a:spcPts val="1200"/>
+                <a:spcPts val="1000"/>
               </a:spcAft>
             </a:pPr>
             <a:r>
-              <a:rPr b="1" sz="1500">
+              <a:rPr b="1" sz="1400">
                 <a:solidFill>
                   <a:srgbClr val="141414"/>
                 </a:solidFill>
@@ -6764,22 +6789,22 @@
               <a:t>❖  </a:t>
             </a:r>
             <a:r>
-              <a:rPr b="1" sz="1400">
+              <a:rPr b="1" sz="1300">
                 <a:solidFill>
                   <a:srgbClr val="1B365D"/>
                 </a:solidFill>
                 <a:latin typeface="Times New Roman"/>
               </a:rPr>
-              <a:t>BHASHINI &amp; AI4BHARAT MULTILINGUAL RESEARCH:  </a:t>
-            </a:r>
-            <a:r>
-              <a:rPr u="sng" sz="1300">
+              <a:t>RESEARCH ON RAG &amp; CITATIONS (LEWIS ET AL. 2020):  </a:t>
+            </a:r>
+            <a:r>
+              <a:rPr u="sng" sz="1200">
                 <a:solidFill>
                   <a:srgbClr val="0077C8"/>
                 </a:solidFill>
                 <a:latin typeface="Arial"/>
               </a:rPr>
-              <a:t>https://bhashini.gov.in</a:t>
+              <a:t>https://arxiv.org/abs/2005.11401</a:t>
             </a:r>
           </a:p>
         </p:txBody>

</xml_diff>

<commit_message>
Integrate official red HRL brand logo across webpage (Navbar, Header, Memo, Slides, Footer, Favicon) and PowerPoint pitch deck
</commit_message>
<xml_diff>
--- a/SIH2026_Idea_Presentation_PS26154.pptx
+++ b/SIH2026_Idea_Presentation_PS26154.pptx
@@ -3329,7 +3329,7 @@
       </p:sp>
       <p:pic>
         <p:nvPicPr>
-          <p:cNvPr id="4" name="Picture 3" descr="sih_official_logo.png"/>
+          <p:cNvPr id="4" name="Picture 3" descr="hrl_brand_logo.png"/>
           <p:cNvPicPr>
             <a:picLocks noChangeAspect="1"/>
           </p:cNvPicPr>
@@ -3343,8 +3343,8 @@
         </p:blipFill>
         <p:spPr>
           <a:xfrm>
-            <a:off x="8412480" y="1645920"/>
-            <a:ext cx="3291840" cy="1695134"/>
+            <a:off x="8595360" y="2011680"/>
+            <a:ext cx="3017520" cy="1090602"/>
           </a:xfrm>
           <a:prstGeom prst="rect">
             <a:avLst/>
@@ -3411,15 +3411,15 @@
           <a:lstStyle/>
           <a:p>
             <a:pPr algn="ctr">
-              <a:defRPr sz="1200" b="1">
+              <a:defRPr b="1" sz="1300">
                 <a:solidFill>
                   <a:srgbClr val="1B365D"/>
                 </a:solidFill>
-                <a:latin typeface="Arial"/>
+                <a:latin typeface="Times New Roman"/>
               </a:defRPr>
             </a:pPr>
             <a:r>
-              <a:t>OmniTransform</a:t>
+              <a:t>TEAM: HRL</a:t>
             </a:r>
           </a:p>
         </p:txBody>
@@ -4394,15 +4394,15 @@
           <a:lstStyle/>
           <a:p>
             <a:pPr algn="ctr">
-              <a:defRPr sz="1200" b="1">
+              <a:defRPr b="1" sz="1300">
                 <a:solidFill>
                   <a:srgbClr val="1B365D"/>
                 </a:solidFill>
-                <a:latin typeface="Arial"/>
+                <a:latin typeface="Times New Roman"/>
               </a:defRPr>
             </a:pPr>
             <a:r>
-              <a:t>OmniTransform</a:t>
+              <a:t>TEAM: HRL</a:t>
             </a:r>
           </a:p>
         </p:txBody>
@@ -4947,15 +4947,15 @@
           <a:lstStyle/>
           <a:p>
             <a:pPr algn="ctr">
-              <a:defRPr sz="1200" b="1">
+              <a:defRPr b="1" sz="1300">
                 <a:solidFill>
                   <a:srgbClr val="1B365D"/>
                 </a:solidFill>
-                <a:latin typeface="Arial"/>
+                <a:latin typeface="Times New Roman"/>
               </a:defRPr>
             </a:pPr>
             <a:r>
-              <a:t>OmniTransform</a:t>
+              <a:t>TEAM: HRL</a:t>
             </a:r>
           </a:p>
         </p:txBody>
@@ -5568,15 +5568,15 @@
           <a:lstStyle/>
           <a:p>
             <a:pPr algn="ctr">
-              <a:defRPr sz="1200" b="1">
+              <a:defRPr b="1" sz="1300">
                 <a:solidFill>
                   <a:srgbClr val="1B365D"/>
                 </a:solidFill>
-                <a:latin typeface="Arial"/>
+                <a:latin typeface="Times New Roman"/>
               </a:defRPr>
             </a:pPr>
             <a:r>
-              <a:t>OmniTransform</a:t>
+              <a:t>TEAM: HRL</a:t>
             </a:r>
           </a:p>
         </p:txBody>
@@ -6400,15 +6400,15 @@
           <a:lstStyle/>
           <a:p>
             <a:pPr algn="ctr">
-              <a:defRPr sz="1200" b="1">
+              <a:defRPr b="1" sz="1300">
                 <a:solidFill>
                   <a:srgbClr val="1B365D"/>
                 </a:solidFill>
-                <a:latin typeface="Arial"/>
+                <a:latin typeface="Times New Roman"/>
               </a:defRPr>
             </a:pPr>
             <a:r>
-              <a:t>OmniTransform</a:t>
+              <a:t>TEAM: HRL</a:t>
             </a:r>
           </a:p>
         </p:txBody>

</xml_diff>

<commit_message>
Standardize entity name to HRL across all components, documents, and PPTX pitch deck (removed Team prefix)
</commit_message>
<xml_diff>
--- a/SIH2026_Idea_Presentation_PS26154.pptx
+++ b/SIH2026_Idea_Presentation_PS26154.pptx
@@ -3419,7 +3419,7 @@
               </a:defRPr>
             </a:pPr>
             <a:r>
-              <a:t>TEAM: HRL</a:t>
+              <a:t>HRL</a:t>
             </a:r>
           </a:p>
         </p:txBody>
@@ -4402,7 +4402,7 @@
               </a:defRPr>
             </a:pPr>
             <a:r>
-              <a:t>TEAM: HRL</a:t>
+              <a:t>HRL</a:t>
             </a:r>
           </a:p>
         </p:txBody>
@@ -4955,7 +4955,7 @@
               </a:defRPr>
             </a:pPr>
             <a:r>
-              <a:t>TEAM: HRL</a:t>
+              <a:t>HRL</a:t>
             </a:r>
           </a:p>
         </p:txBody>
@@ -5576,7 +5576,7 @@
               </a:defRPr>
             </a:pPr>
             <a:r>
-              <a:t>TEAM: HRL</a:t>
+              <a:t>HRL</a:t>
             </a:r>
           </a:p>
         </p:txBody>
@@ -6408,7 +6408,7 @@
               </a:defRPr>
             </a:pPr>
             <a:r>
-              <a:t>TEAM: HRL</a:t>
+              <a:t>HRL</a:t>
             </a:r>
           </a:p>
         </p:txBody>

</xml_diff>